<commit_message>
Crivo R3: S24 barra do meio a meio, S50 faixa 7-10, marshmallow sem fracao fixa, ressalvas Eisenberger/variacao lexical/decalage; aula oficial final
Co-Authored-By: Claude Fable 5 <noreply@anthropic.com>
Claude-Session: https://claude.ai/code/session_018axhg2YPoGkj2YuJKRU4fe
</commit_message>
<xml_diff>
--- a/aulas/desenvolvimento-normal-2-anos-puberdade/deck/AULA-OFICIAL_Desenvolvimento-normal-2a-puberdade_PsiquiatriaPratica.pptx
+++ b/aulas/desenvolvimento-normal-2-anos-puberdade/deck/AULA-OFICIAL_Desenvolvimento-normal-2a-puberdade_PsiquiatriaPratica.pptx
@@ -1027,7 +1027,7 @@
           <a:p>
             <a:r>
               <a:rPr lang="en-US" dirty="0"/>
-              <a:t>A pergunta 'o que ela obteve?' prepara a gênese do TOD no Ato 2. Plantar sem colher ainda.</a:t>
+              <a:t>A pergunta 'o que ela obteve?' prepara a contracena do Ato 2. Plantar sem colher ainda. Ressalva de fala: UM episódio gera hipótese; análise funcional de verdade exige padrão em várias ocorrências (apêndice A).</a:t>
             </a:r>
             <a:endParaRPr lang="en-US" dirty="0"/>
           </a:p>
@@ -1995,7 +1995,7 @@
           <a:p>
             <a:r>
               <a:rPr lang="en-US" dirty="0"/>
-              <a:t>Preditores: faz de conta compartilhado, memória de trabalho e LINGUAGEM (limiar linguístico para passar em crença falsa). Velocidade de aquisição prediz habilidade social futura. Nuance no apêndice C: a transição é gradual (Wellman), sem idade-muro.</a:t>
+              <a:t>Preditores: faz de conta compartilhado, memória de trabalho e LINGUAGEM (limiar linguístico para passar em crença falsa). Velocidade de aquisição prediz habilidade social futura. Nuance no apêndice C: a transição é gradual (Wellman), sem idade-muro; criança de 4 que erra não está atrasada por isso.</a:t>
             </a:r>
             <a:endParaRPr lang="en-US" dirty="0"/>
           </a:p>
@@ -2611,7 +2611,7 @@
           <a:p>
             <a:r>
               <a:rPr lang="en-US" dirty="0"/>
-              <a:t>Gênese funcional: oposição é comportamento operante. Quando resistir desliga a ordem (reforço negativo) ou captura o adulto (reforço positivo), a oposição é selecionada. Pergunta clínica: 'o que a oposição PRODUZ nesta casa?'. Contraste: o desafio aberto normalmente DECLINA dos 2 aos 6.</a:t>
+              <a:t>Gênese funcional: oposição é comportamento operante, sem intenção consciente e sem vilão. Quando resistir desliga a ordem (reforço negativo) ou captura o adulto (reforço positivo), a oposição é selecionada. Ressalva obrigatória: fator de risco e de manutenção, NÃO causa suficiente (temperamento e carga familiar entram na equação; apêndice A). Pergunta clínica: 'o que a oposição PRODUZ nesta casa?'. Contraste: o desafio aberto normalmente DECLINA dos 2 aos 6.</a:t>
             </a:r>
             <a:endParaRPr lang="en-US" dirty="0"/>
           </a:p>
@@ -3227,7 +3227,7 @@
           <a:p>
             <a:r>
               <a:rPr lang="en-US" dirty="0"/>
-              <a:t>Se perguntarem 'Piaget não foi superado?': os fenômenos replicam; a explicação mudou (Siegler: regras adquiridas por experiência + processamento). Mapa sim, mecanismo não.</a:t>
+              <a:t>Se perguntarem 'Piaget não foi superado?': os fenômenos replicam; a explicação mudou (Siegler: regras adquiridas por experiência + processamento). Mapa sim, mecanismo não. Nota de fonte: massa 7 / peso 8 / volume 11 é a sequência do Bee &amp; Boyd p. 241 (Tomlinson-Keasey); parte da literatura situa peso perto dos 9.</a:t>
             </a:r>
             <a:endParaRPr lang="en-US" dirty="0"/>
           </a:p>
@@ -3755,7 +3755,7 @@
           <a:p>
             <a:r>
               <a:rPr lang="en-US" dirty="0"/>
-              <a:t>O que continua valendo: a melhor IMAGEM do freio imaturo em ação (as estratégias de distração SÃO autorregulação nascente). O que morreu: o oráculo. Ensinar o residente a citar sem folclore.</a:t>
+              <a:t>O que continua valendo: a melhor IMAGEM do freio imaturo em ação (as estratégias de distração SÃO autorregulação nascente). O que morreu: o oráculo. Precisão para a fala: com controles completos de família e cognição precoce, a maior parte do efeito desaparece (não significativo em vários modelos de Watts 2018); evitar fração fixa.</a:t>
             </a:r>
             <a:endParaRPr lang="en-US" dirty="0"/>
           </a:p>
@@ -4635,7 +4635,7 @@
           <a:p>
             <a:r>
               <a:rPr lang="en-US" dirty="0"/>
-              <a:t>Status sociométrico: comportamento social pesa mais que aparência (Rodkin 2013).</a:t>
+              <a:t>Status sociométrico: comportamento social pesa mais que aparência (Rodkin 2013). Ressalva de fala sobre Eisenberger: achado clássico e útil como ILUSTRAÇÃO, mas a leitura 'mesma área = mesmo mecanismo' foi questionada por análises multivariadas posteriores; não usar como prova de identidade neural.</a:t>
             </a:r>
             <a:endParaRPr lang="en-US" dirty="0"/>
           </a:p>
@@ -6395,7 +6395,7 @@
           <a:p>
             <a:r>
               <a:rPr lang="en-US" dirty="0"/>
-              <a:t>Superregularização ('fazi', 'sabo') é sinal de saúde: a criança extraiu a regra e aplicou demais. Erro que denuncia inteligência do sistema.</a:t>
+              <a:t>Superregularização ('fazi', 'sabo') é sinal de saúde: a criança extraiu a regra e aplicou demais. Erro que denuncia inteligência do sistema. Ressalva de fala: 600 e 15.000 são MÉDIAS com variação individual enorme; não usar como marco de alarme isolado.</a:t>
             </a:r>
             <a:endParaRPr lang="en-US" dirty="0"/>
           </a:p>
@@ -10418,7 +10418,7 @@
                 <a:ea typeface="Georgia" pitchFamily="34" charset="-122"/>
                 <a:cs typeface="Georgia" pitchFamily="34" charset="-120"/>
               </a:rPr>
-              <a:t>Toda birra tem gramática (gatilho, escalada, função), e ler essa gramática se chama análise funcional.</a:t>
+              <a:t>Toda birra tem gramática (gatilho, escalada, função), e ler essa gramática é o primeiro passo da análise funcional.</a:t>
             </a:r>
             <a:endParaRPr lang="en-US" sz="2100" dirty="0"/>
           </a:p>
@@ -12342,7 +12342,7 @@
                 <a:ea typeface="Calibri" pitchFamily="34" charset="-122"/>
                 <a:cs typeface="Calibri" pitchFamily="34" charset="-120"/>
               </a:rPr>
-              <a:t>atenção compartilhada / M-CHAT · janela do segundo ano</a:t>
+              <a:t>atenção compartilhada · M-CHAT-R (Modified Checklist for Autism in Toddlers, rastreio 16-30 meses)</a:t>
             </a:r>
             <a:endParaRPr lang="en-US" sz="1100" dirty="0"/>
           </a:p>
@@ -14704,9 +14704,48 @@
                 <a:ea typeface="Calibri" pitchFamily="34" charset="-122"/>
                 <a:cs typeface="Calibri" pitchFamily="34" charset="-120"/>
               </a:rPr>
-              <a:t>Votem: com que idade a criança passa a acertar? 2, 3, 4 ou 6?</a:t>
+              <a:t>Votem: com que idade a MAIORIA das crianças passa a acertar? 2, 3, 4 ou 6?</a:t>
             </a:r>
             <a:endParaRPr lang="en-US" sz="1350" dirty="0"/>
+          </a:p>
+        </p:txBody>
+      </p:sp>
+      <p:sp>
+        <p:nvSpPr>
+          <p:cNvPr id="10" name="Text 7"/>
+          <p:cNvSpPr/>
+          <p:nvPr/>
+        </p:nvSpPr>
+        <p:spPr>
+          <a:xfrm>
+            <a:off x="8897112" y="6455664"/>
+            <a:ext cx="2560320" cy="292608"/>
+          </a:xfrm>
+          <a:prstGeom prst="rect">
+            <a:avLst/>
+          </a:prstGeom>
+          <a:noFill/>
+          <a:ln/>
+        </p:spPr>
+        <p:txBody>
+          <a:bodyPr wrap="square" rtlCol="0" anchor="ctr"/>
+          <a:lstStyle/>
+          <a:p>
+            <a:pPr algn="r" indent="0" marL="0">
+              <a:buNone/>
+            </a:pPr>
+            <a:r>
+              <a:rPr lang="en-US" sz="1000" i="1" dirty="0">
+                <a:solidFill>
+                  <a:srgbClr val="8A6594"/>
+                </a:solidFill>
+                <a:latin typeface="Calibri" pitchFamily="34" charset="0"/>
+                <a:ea typeface="Calibri" pitchFamily="34" charset="-122"/>
+                <a:cs typeface="Calibri" pitchFamily="34" charset="-120"/>
+              </a:rPr>
+              <a:t>aprofundamento: apêndice C</a:t>
+            </a:r>
+            <a:endParaRPr lang="en-US" sz="1000" dirty="0"/>
           </a:p>
         </p:txBody>
       </p:sp>
@@ -15165,7 +15204,7 @@
               <a:buNone/>
             </a:pPr>
             <a:r>
-              <a:rPr lang="en-US" sz="2300" b="1" dirty="0">
+              <a:rPr lang="en-US" sz="2100" b="1" dirty="0">
                 <a:solidFill>
                   <a:srgbClr val="56365F"/>
                 </a:solidFill>
@@ -15173,9 +15212,9 @@
                 <a:ea typeface="Georgia" pitchFamily="34" charset="-122"/>
                 <a:cs typeface="Georgia" pitchFamily="34" charset="-120"/>
               </a:rPr>
-              <a:t>Aos 3 a criança erra, aos 4-5 acerta, e o padrão se repete em toda cultura testada.</a:t>
-            </a:r>
-            <a:endParaRPr lang="en-US" sz="2300" dirty="0"/>
+              <a:t>Aos 3 a maioria erra, aos 5 a maioria acerta, e o padrão se repete em toda cultura testada.</a:t>
+            </a:r>
+            <a:endParaRPr lang="en-US" sz="2100" dirty="0"/>
           </a:p>
         </p:txBody>
       </p:sp>
@@ -15227,8 +15266,8 @@
         </p:nvSpPr>
         <p:spPr>
           <a:xfrm>
-            <a:off x="2194560" y="5029200"/>
-            <a:ext cx="1920240" cy="640080"/>
+            <a:off x="2240280" y="5029200"/>
+            <a:ext cx="1828800" cy="640080"/>
           </a:xfrm>
           <a:prstGeom prst="rect">
             <a:avLst/>
@@ -15244,7 +15283,7 @@
               <a:buNone/>
             </a:pPr>
             <a:r>
-              <a:rPr lang="en-US" sz="1400" b="1" dirty="0">
+              <a:rPr lang="en-US" sz="1250" b="1" dirty="0">
                 <a:solidFill>
                   <a:srgbClr val="56365F"/>
                 </a:solidFill>
@@ -15252,16 +15291,16 @@
                 <a:ea typeface="Calibri" pitchFamily="34" charset="-122"/>
                 <a:cs typeface="Calibri" pitchFamily="34" charset="-120"/>
               </a:rPr>
-              <a:t>3 anos</a:t>
-            </a:r>
-            <a:endParaRPr lang="en-US" sz="1400" dirty="0"/>
+              <a:t>3 anos:</a:t>
+            </a:r>
+            <a:endParaRPr lang="en-US" sz="1250" dirty="0"/>
           </a:p>
           <a:p>
             <a:pPr algn="ctr" indent="0" marL="0">
               <a:buNone/>
             </a:pPr>
             <a:r>
-              <a:rPr lang="en-US" sz="1400" b="1" dirty="0">
+              <a:rPr lang="en-US" sz="1250" b="1" dirty="0">
                 <a:solidFill>
                   <a:srgbClr val="56365F"/>
                 </a:solidFill>
@@ -15269,15 +15308,91 @@
                 <a:ea typeface="Calibri" pitchFamily="34" charset="-122"/>
                 <a:cs typeface="Calibri" pitchFamily="34" charset="-120"/>
               </a:rPr>
-              <a:t>erra</a:t>
-            </a:r>
-            <a:endParaRPr lang="en-US" sz="1400" dirty="0"/>
+              <a:t>a maioria erra</a:t>
+            </a:r>
+            <a:endParaRPr lang="en-US" sz="1250" dirty="0"/>
           </a:p>
         </p:txBody>
       </p:sp>
       <p:sp>
         <p:nvSpPr>
           <p:cNvPr id="8" name="Shape 6"/>
+          <p:cNvSpPr/>
+          <p:nvPr/>
+        </p:nvSpPr>
+        <p:spPr>
+          <a:xfrm>
+            <a:off x="4023360" y="3703320"/>
+            <a:ext cx="1554480" cy="1234440"/>
+          </a:xfrm>
+          <a:prstGeom prst="rect">
+            <a:avLst/>
+          </a:prstGeom>
+          <a:solidFill>
+            <a:srgbClr val="ECB841"/>
+          </a:solidFill>
+          <a:ln/>
+        </p:spPr>
+      </p:sp>
+      <p:sp>
+        <p:nvSpPr>
+          <p:cNvPr id="9" name="Text 7"/>
+          <p:cNvSpPr/>
+          <p:nvPr/>
+        </p:nvSpPr>
+        <p:spPr>
+          <a:xfrm>
+            <a:off x="3886200" y="5029200"/>
+            <a:ext cx="1828800" cy="640080"/>
+          </a:xfrm>
+          <a:prstGeom prst="rect">
+            <a:avLst/>
+          </a:prstGeom>
+          <a:noFill/>
+          <a:ln/>
+        </p:spPr>
+        <p:txBody>
+          <a:bodyPr wrap="square" rtlCol="0" anchor="t"/>
+          <a:lstStyle/>
+          <a:p>
+            <a:pPr algn="ctr" indent="0" marL="0">
+              <a:buNone/>
+            </a:pPr>
+            <a:r>
+              <a:rPr lang="en-US" sz="1250" b="1" dirty="0">
+                <a:solidFill>
+                  <a:srgbClr val="8A6594"/>
+                </a:solidFill>
+                <a:latin typeface="Calibri" pitchFamily="34" charset="0"/>
+                <a:ea typeface="Calibri" pitchFamily="34" charset="-122"/>
+                <a:cs typeface="Calibri" pitchFamily="34" charset="-120"/>
+              </a:rPr>
+              <a:t>4 anos:</a:t>
+            </a:r>
+            <a:endParaRPr lang="en-US" sz="1250" dirty="0"/>
+          </a:p>
+          <a:p>
+            <a:pPr algn="ctr" indent="0" marL="0">
+              <a:buNone/>
+            </a:pPr>
+            <a:r>
+              <a:rPr lang="en-US" sz="1250" b="1" dirty="0">
+                <a:solidFill>
+                  <a:srgbClr val="8A6594"/>
+                </a:solidFill>
+                <a:latin typeface="Calibri" pitchFamily="34" charset="0"/>
+                <a:ea typeface="Calibri" pitchFamily="34" charset="-122"/>
+                <a:cs typeface="Calibri" pitchFamily="34" charset="-120"/>
+              </a:rPr>
+              <a:t>meio a meio</a:t>
+            </a:r>
+            <a:endParaRPr lang="en-US" sz="1250" dirty="0"/>
+          </a:p>
+        </p:txBody>
+      </p:sp>
+      <p:sp>
+        <p:nvSpPr>
+          <p:cNvPr id="10" name="Shape 8"/>
           <p:cNvSpPr/>
           <p:nvPr/>
         </p:nvSpPr>
@@ -15297,7 +15412,7 @@
       </p:sp>
       <p:sp>
         <p:nvSpPr>
-          <p:cNvPr id="9" name="Shape 7"/>
+          <p:cNvPr id="11" name="Shape 9"/>
           <p:cNvSpPr/>
           <p:nvPr/>
         </p:nvSpPr>
@@ -15320,14 +15435,14 @@
       </p:sp>
       <p:sp>
         <p:nvSpPr>
-          <p:cNvPr id="10" name="Text 8"/>
-          <p:cNvSpPr/>
-          <p:nvPr/>
-        </p:nvSpPr>
-        <p:spPr>
-          <a:xfrm>
-            <a:off x="5486400" y="5029200"/>
-            <a:ext cx="1920240" cy="640080"/>
+          <p:cNvPr id="12" name="Text 10"/>
+          <p:cNvSpPr/>
+          <p:nvPr/>
+        </p:nvSpPr>
+        <p:spPr>
+          <a:xfrm>
+            <a:off x="5532120" y="5029200"/>
+            <a:ext cx="1828800" cy="640080"/>
           </a:xfrm>
           <a:prstGeom prst="rect">
             <a:avLst/>
@@ -15343,7 +15458,7 @@
               <a:buNone/>
             </a:pPr>
             <a:r>
-              <a:rPr lang="en-US" sz="1400" b="1" dirty="0">
+              <a:rPr lang="en-US" sz="1250" b="1" dirty="0">
                 <a:solidFill>
                   <a:srgbClr val="B84A1F"/>
                 </a:solidFill>
@@ -15351,16 +15466,16 @@
                 <a:ea typeface="Calibri" pitchFamily="34" charset="-122"/>
                 <a:cs typeface="Calibri" pitchFamily="34" charset="-120"/>
               </a:rPr>
-              <a:t>4-5 anos</a:t>
-            </a:r>
-            <a:endParaRPr lang="en-US" sz="1400" dirty="0"/>
+              <a:t>5 anos:</a:t>
+            </a:r>
+            <a:endParaRPr lang="en-US" sz="1250" dirty="0"/>
           </a:p>
           <a:p>
             <a:pPr algn="ctr" indent="0" marL="0">
               <a:buNone/>
             </a:pPr>
             <a:r>
-              <a:rPr lang="en-US" sz="1400" b="1" dirty="0">
+              <a:rPr lang="en-US" sz="1250" b="1" dirty="0">
                 <a:solidFill>
                   <a:srgbClr val="B84A1F"/>
                 </a:solidFill>
@@ -15368,15 +15483,15 @@
                 <a:ea typeface="Calibri" pitchFamily="34" charset="-122"/>
                 <a:cs typeface="Calibri" pitchFamily="34" charset="-120"/>
               </a:rPr>
-              <a:t>acerta</a:t>
-            </a:r>
-            <a:endParaRPr lang="en-US" sz="1400" dirty="0"/>
-          </a:p>
-        </p:txBody>
-      </p:sp>
-      <p:sp>
-        <p:nvSpPr>
-          <p:cNvPr id="11" name="Shape 9"/>
+              <a:t>a maioria acerta</a:t>
+            </a:r>
+            <a:endParaRPr lang="en-US" sz="1250" dirty="0"/>
+          </a:p>
+        </p:txBody>
+      </p:sp>
+      <p:sp>
+        <p:nvSpPr>
+          <p:cNvPr id="13" name="Shape 11"/>
           <p:cNvSpPr/>
           <p:nvPr/>
         </p:nvSpPr>
@@ -15403,7 +15518,7 @@
       </p:sp>
       <p:sp>
         <p:nvSpPr>
-          <p:cNvPr id="12" name="Text 10"/>
+          <p:cNvPr id="14" name="Text 12"/>
           <p:cNvSpPr/>
           <p:nvPr/>
         </p:nvSpPr>
@@ -15442,7 +15557,7 @@
       </p:sp>
       <p:sp>
         <p:nvSpPr>
-          <p:cNvPr id="13" name="Text 11"/>
+          <p:cNvPr id="15" name="Text 13"/>
           <p:cNvSpPr/>
           <p:nvPr/>
         </p:nvSpPr>
@@ -15481,7 +15596,7 @@
       </p:sp>
       <p:sp>
         <p:nvSpPr>
-          <p:cNvPr id="14" name="Text 12"/>
+          <p:cNvPr id="16" name="Text 14"/>
           <p:cNvSpPr/>
           <p:nvPr/>
         </p:nvSpPr>
@@ -18059,7 +18174,46 @@
       </p:sp>
       <p:sp>
         <p:nvSpPr>
-          <p:cNvPr id="19" name="Shape 17"/>
+          <p:cNvPr id="19" name="Text 17"/>
+          <p:cNvSpPr/>
+          <p:nvPr/>
+        </p:nvSpPr>
+        <p:spPr>
+          <a:xfrm>
+            <a:off x="1280160" y="5257800"/>
+            <a:ext cx="9601200" cy="320040"/>
+          </a:xfrm>
+          <a:prstGeom prst="rect">
+            <a:avLst/>
+          </a:prstGeom>
+          <a:noFill/>
+          <a:ln/>
+        </p:spPr>
+        <p:txBody>
+          <a:bodyPr wrap="square" rtlCol="0" anchor="t"/>
+          <a:lstStyle/>
+          <a:p>
+            <a:pPr indent="0" marL="0">
+              <a:buNone/>
+            </a:pPr>
+            <a:r>
+              <a:rPr lang="en-US" sz="1200" i="1" dirty="0">
+                <a:solidFill>
+                  <a:srgbClr val="B84A1F"/>
+                </a:solidFill>
+                <a:latin typeface="Calibri" pitchFamily="34" charset="0"/>
+                <a:ea typeface="Calibri" pitchFamily="34" charset="-122"/>
+                <a:cs typeface="Calibri" pitchFamily="34" charset="-120"/>
+              </a:rPr>
+              <a:t>posição no mapa = etapa da transferência que costuma falhar, NÃO idade de início</a:t>
+            </a:r>
+            <a:endParaRPr lang="en-US" sz="1200" dirty="0"/>
+          </a:p>
+        </p:txBody>
+      </p:sp>
+      <p:sp>
+        <p:nvSpPr>
+          <p:cNvPr id="20" name="Shape 18"/>
           <p:cNvSpPr/>
           <p:nvPr/>
         </p:nvSpPr>
@@ -18086,7 +18240,7 @@
       </p:sp>
       <p:sp>
         <p:nvSpPr>
-          <p:cNvPr id="20" name="Shape 18"/>
+          <p:cNvPr id="21" name="Shape 19"/>
           <p:cNvSpPr/>
           <p:nvPr/>
         </p:nvSpPr>
@@ -18106,7 +18260,7 @@
       </p:sp>
       <p:sp>
         <p:nvSpPr>
-          <p:cNvPr id="21" name="Text 19"/>
+          <p:cNvPr id="22" name="Text 20"/>
           <p:cNvSpPr/>
           <p:nvPr/>
         </p:nvSpPr>
@@ -18145,7 +18299,7 @@
       </p:sp>
       <p:sp>
         <p:nvSpPr>
-          <p:cNvPr id="22" name="Text 20"/>
+          <p:cNvPr id="23" name="Text 21"/>
           <p:cNvSpPr/>
           <p:nvPr/>
         </p:nvSpPr>
@@ -18184,7 +18338,7 @@
       </p:sp>
       <p:sp>
         <p:nvSpPr>
-          <p:cNvPr id="23" name="Shape 21"/>
+          <p:cNvPr id="24" name="Shape 22"/>
           <p:cNvSpPr/>
           <p:nvPr/>
         </p:nvSpPr>
@@ -18207,7 +18361,7 @@
       </p:sp>
       <p:sp>
         <p:nvSpPr>
-          <p:cNvPr id="24" name="Shape 22"/>
+          <p:cNvPr id="25" name="Shape 23"/>
           <p:cNvSpPr/>
           <p:nvPr/>
         </p:nvSpPr>
@@ -18234,7 +18388,7 @@
       </p:sp>
       <p:sp>
         <p:nvSpPr>
-          <p:cNvPr id="25" name="Shape 23"/>
+          <p:cNvPr id="26" name="Shape 24"/>
           <p:cNvSpPr/>
           <p:nvPr/>
         </p:nvSpPr>
@@ -18254,7 +18408,7 @@
       </p:sp>
       <p:sp>
         <p:nvSpPr>
-          <p:cNvPr id="26" name="Text 24"/>
+          <p:cNvPr id="27" name="Text 25"/>
           <p:cNvSpPr/>
           <p:nvPr/>
         </p:nvSpPr>
@@ -18293,7 +18447,7 @@
       </p:sp>
       <p:sp>
         <p:nvSpPr>
-          <p:cNvPr id="27" name="Text 25"/>
+          <p:cNvPr id="28" name="Text 26"/>
           <p:cNvSpPr/>
           <p:nvPr/>
         </p:nvSpPr>
@@ -18332,7 +18486,7 @@
       </p:sp>
       <p:sp>
         <p:nvSpPr>
-          <p:cNvPr id="28" name="Shape 26"/>
+          <p:cNvPr id="29" name="Shape 27"/>
           <p:cNvSpPr/>
           <p:nvPr/>
         </p:nvSpPr>
@@ -18355,7 +18509,7 @@
       </p:sp>
       <p:sp>
         <p:nvSpPr>
-          <p:cNvPr id="29" name="Shape 27"/>
+          <p:cNvPr id="30" name="Shape 28"/>
           <p:cNvSpPr/>
           <p:nvPr/>
         </p:nvSpPr>
@@ -18382,7 +18536,7 @@
       </p:sp>
       <p:sp>
         <p:nvSpPr>
-          <p:cNvPr id="30" name="Shape 28"/>
+          <p:cNvPr id="31" name="Shape 29"/>
           <p:cNvSpPr/>
           <p:nvPr/>
         </p:nvSpPr>
@@ -18402,7 +18556,7 @@
       </p:sp>
       <p:sp>
         <p:nvSpPr>
-          <p:cNvPr id="31" name="Text 29"/>
+          <p:cNvPr id="32" name="Text 30"/>
           <p:cNvSpPr/>
           <p:nvPr/>
         </p:nvSpPr>
@@ -18441,7 +18595,7 @@
       </p:sp>
       <p:sp>
         <p:nvSpPr>
-          <p:cNvPr id="32" name="Text 30"/>
+          <p:cNvPr id="33" name="Text 31"/>
           <p:cNvSpPr/>
           <p:nvPr/>
         </p:nvSpPr>
@@ -18480,7 +18634,7 @@
       </p:sp>
       <p:sp>
         <p:nvSpPr>
-          <p:cNvPr id="33" name="Shape 31"/>
+          <p:cNvPr id="34" name="Shape 32"/>
           <p:cNvSpPr/>
           <p:nvPr/>
         </p:nvSpPr>
@@ -18503,7 +18657,7 @@
       </p:sp>
       <p:sp>
         <p:nvSpPr>
-          <p:cNvPr id="34" name="Shape 32"/>
+          <p:cNvPr id="35" name="Shape 33"/>
           <p:cNvSpPr/>
           <p:nvPr/>
         </p:nvSpPr>
@@ -18530,7 +18684,7 @@
       </p:sp>
       <p:sp>
         <p:nvSpPr>
-          <p:cNvPr id="35" name="Shape 33"/>
+          <p:cNvPr id="36" name="Shape 34"/>
           <p:cNvSpPr/>
           <p:nvPr/>
         </p:nvSpPr>
@@ -18550,7 +18704,7 @@
       </p:sp>
       <p:sp>
         <p:nvSpPr>
-          <p:cNvPr id="36" name="Text 34"/>
+          <p:cNvPr id="37" name="Text 35"/>
           <p:cNvSpPr/>
           <p:nvPr/>
         </p:nvSpPr>
@@ -18589,7 +18743,7 @@
       </p:sp>
       <p:sp>
         <p:nvSpPr>
-          <p:cNvPr id="37" name="Text 35"/>
+          <p:cNvPr id="38" name="Text 36"/>
           <p:cNvSpPr/>
           <p:nvPr/>
         </p:nvSpPr>
@@ -18628,7 +18782,7 @@
       </p:sp>
       <p:sp>
         <p:nvSpPr>
-          <p:cNvPr id="38" name="Shape 36"/>
+          <p:cNvPr id="39" name="Shape 37"/>
           <p:cNvSpPr/>
           <p:nvPr/>
         </p:nvSpPr>
@@ -18842,7 +18996,7 @@
                 <a:ea typeface="Georgia" pitchFamily="34" charset="-122"/>
                 <a:cs typeface="Georgia" pitchFamily="34" charset="-120"/>
               </a:rPr>
-              <a:t>Quando resistir FUNCIONA, a oposição vira estratégia: o TOD nasce como aprendizagem antes de virar rótulo.</a:t>
+              <a:t>Quando resistir FUNCIONA, a oposição vira comportamento aprendido: é assim que se arma o risco de transtorno opositivo-desafiador (TOD).</a:t>
             </a:r>
             <a:endParaRPr lang="en-US" sz="2300" dirty="0"/>
           </a:p>
@@ -21196,7 +21350,7 @@
                 <a:ea typeface="Calibri" pitchFamily="34" charset="-122"/>
                 <a:cs typeface="Calibri" pitchFamily="34" charset="-120"/>
               </a:rPr>
-              <a:t>curva de Kail: mais rápido</a:t>
+              <a:t>tempo de reação cai com a</a:t>
             </a:r>
             <a:endParaRPr lang="en-US" sz="1300" dirty="0"/>
           </a:p>
@@ -21213,7 +21367,7 @@
                 <a:ea typeface="Calibri" pitchFamily="34" charset="-122"/>
                 <a:cs typeface="Calibri" pitchFamily="34" charset="-120"/>
               </a:rPr>
-              <a:t>em qualquer cultura</a:t>
+              <a:t>idade (Kail), em qualquer cultura</a:t>
             </a:r>
             <a:endParaRPr lang="en-US" sz="1300" dirty="0"/>
           </a:p>
@@ -22098,12 +22252,12 @@
         </p:nvSpPr>
         <p:spPr>
           <a:xfrm>
-            <a:off x="822960" y="2514600"/>
-            <a:ext cx="2834640" cy="1051560"/>
+            <a:off x="822960" y="2468880"/>
+            <a:ext cx="2834640" cy="1005840"/>
           </a:xfrm>
           <a:prstGeom prst="roundRect">
             <a:avLst>
-              <a:gd name="adj" fmla="val 6087"/>
+              <a:gd name="adj" fmla="val 6364"/>
             </a:avLst>
           </a:prstGeom>
           <a:solidFill>
@@ -22158,12 +22312,12 @@
         </p:nvSpPr>
         <p:spPr>
           <a:xfrm>
-            <a:off x="3931920" y="2514600"/>
-            <a:ext cx="2834640" cy="1051560"/>
+            <a:off x="3931920" y="2468880"/>
+            <a:ext cx="2834640" cy="1005840"/>
           </a:xfrm>
           <a:prstGeom prst="roundRect">
             <a:avLst>
-              <a:gd name="adj" fmla="val 6087"/>
+              <a:gd name="adj" fmla="val 6364"/>
             </a:avLst>
           </a:prstGeom>
           <a:solidFill>
@@ -22218,12 +22372,12 @@
         </p:nvSpPr>
         <p:spPr>
           <a:xfrm>
-            <a:off x="7040880" y="2514600"/>
-            <a:ext cx="2834640" cy="1051560"/>
+            <a:off x="7040880" y="2468880"/>
+            <a:ext cx="2834640" cy="1005840"/>
           </a:xfrm>
           <a:prstGeom prst="roundRect">
             <a:avLst>
-              <a:gd name="adj" fmla="val 6087"/>
+              <a:gd name="adj" fmla="val 6364"/>
             </a:avLst>
           </a:prstGeom>
           <a:solidFill>
@@ -22272,7 +22426,46 @@
       </p:sp>
       <p:sp>
         <p:nvSpPr>
-          <p:cNvPr id="9" name="Shape 7"/>
+          <p:cNvPr id="9" name="Text 7"/>
+          <p:cNvSpPr/>
+          <p:nvPr/>
+        </p:nvSpPr>
+        <p:spPr>
+          <a:xfrm>
+            <a:off x="822960" y="3584448"/>
+            <a:ext cx="10515600" cy="320040"/>
+          </a:xfrm>
+          <a:prstGeom prst="rect">
+            <a:avLst/>
+          </a:prstGeom>
+          <a:noFill/>
+          <a:ln/>
+        </p:spPr>
+        <p:txBody>
+          <a:bodyPr wrap="square" rtlCol="0" anchor="t"/>
+          <a:lstStyle/>
+          <a:p>
+            <a:pPr indent="0" marL="0">
+              <a:buNone/>
+            </a:pPr>
+            <a:r>
+              <a:rPr lang="en-US" sz="1200" i="1" dirty="0">
+                <a:solidFill>
+                  <a:srgbClr val="8A6594"/>
+                </a:solidFill>
+                <a:latin typeface="Calibri" pitchFamily="34" charset="0"/>
+                <a:ea typeface="Calibri" pitchFamily="34" charset="-122"/>
+                <a:cs typeface="Calibri" pitchFamily="34" charset="-120"/>
+              </a:rPr>
+              <a:t>descentração = considerar mais de uma dimensão ao mesmo tempo; a compensação é ela em ação</a:t>
+            </a:r>
+            <a:endParaRPr lang="en-US" sz="1200" dirty="0"/>
+          </a:p>
+        </p:txBody>
+      </p:sp>
+      <p:sp>
+        <p:nvSpPr>
+          <p:cNvPr id="10" name="Shape 8"/>
           <p:cNvSpPr/>
           <p:nvPr/>
         </p:nvSpPr>
@@ -22299,7 +22492,7 @@
       </p:sp>
       <p:sp>
         <p:nvSpPr>
-          <p:cNvPr id="10" name="Text 8"/>
+          <p:cNvPr id="11" name="Text 9"/>
           <p:cNvSpPr/>
           <p:nvPr/>
         </p:nvSpPr>
@@ -22338,7 +22531,7 @@
       </p:sp>
       <p:sp>
         <p:nvSpPr>
-          <p:cNvPr id="11" name="Text 9"/>
+          <p:cNvPr id="12" name="Text 10"/>
           <p:cNvSpPr/>
           <p:nvPr/>
         </p:nvSpPr>
@@ -23167,8 +23360,8 @@
         </p:nvSpPr>
         <p:spPr>
           <a:xfrm>
-            <a:off x="8138160" y="3977640"/>
-            <a:ext cx="3108960" cy="365760"/>
+            <a:off x="8001000" y="3566160"/>
+            <a:ext cx="3291840" cy="365760"/>
           </a:xfrm>
           <a:prstGeom prst="rect">
             <a:avLst/>
@@ -23184,7 +23377,7 @@
               <a:buNone/>
             </a:pPr>
             <a:r>
-              <a:rPr lang="en-US" sz="1250" b="1" dirty="0">
+              <a:rPr lang="en-US" sz="1200" b="1" dirty="0">
                 <a:solidFill>
                   <a:srgbClr val="56365F"/>
                 </a:solidFill>
@@ -23192,9 +23385,9 @@
                 <a:ea typeface="Calibri" pitchFamily="34" charset="-122"/>
                 <a:cs typeface="Calibri" pitchFamily="34" charset="-120"/>
               </a:rPr>
-              <a:t>maturação do freio (contínua)</a:t>
-            </a:r>
-            <a:endParaRPr lang="en-US" sz="1250" dirty="0"/>
+              <a:t>freio típico (maturação contínua)</a:t>
+            </a:r>
+            <a:endParaRPr lang="en-US" sz="1200" dirty="0"/>
           </a:p>
         </p:txBody>
       </p:sp>
@@ -23206,8 +23399,110 @@
         </p:nvSpPr>
         <p:spPr>
           <a:xfrm>
+            <a:off x="1463040" y="5349240"/>
+            <a:ext cx="4023360" cy="-685800"/>
+          </a:xfrm>
+          <a:prstGeom prst="line">
+            <a:avLst/>
+          </a:prstGeom>
+          <a:noFill/>
+          <a:ln w="44450">
+            <a:solidFill>
+              <a:srgbClr val="8A6594"/>
+            </a:solidFill>
+            <a:prstDash val="dash"/>
+          </a:ln>
+        </p:spPr>
+      </p:sp>
+      <p:sp>
+        <p:nvSpPr>
+          <p:cNvPr id="13" name="Shape 11"/>
+          <p:cNvSpPr/>
+          <p:nvPr/>
+        </p:nvSpPr>
+        <p:spPr>
+          <a:xfrm>
+            <a:off x="5486400" y="4663440"/>
+            <a:ext cx="4846320" cy="-640080"/>
+          </a:xfrm>
+          <a:prstGeom prst="line">
+            <a:avLst/>
+          </a:prstGeom>
+          <a:noFill/>
+          <a:ln w="44450">
+            <a:solidFill>
+              <a:srgbClr val="8A6594"/>
+            </a:solidFill>
+            <a:prstDash val="dash"/>
+          </a:ln>
+        </p:spPr>
+      </p:sp>
+      <p:sp>
+        <p:nvSpPr>
+          <p:cNvPr id="14" name="Text 12"/>
+          <p:cNvSpPr/>
+          <p:nvPr/>
+        </p:nvSpPr>
+        <p:spPr>
+          <a:xfrm>
+            <a:off x="8001000" y="4892040"/>
+            <a:ext cx="3291840" cy="548640"/>
+          </a:xfrm>
+          <a:prstGeom prst="rect">
+            <a:avLst/>
+          </a:prstGeom>
+          <a:noFill/>
+          <a:ln/>
+        </p:spPr>
+        <p:txBody>
+          <a:bodyPr wrap="square" rtlCol="0" anchor="t"/>
+          <a:lstStyle/>
+          <a:p>
+            <a:pPr indent="0" marL="0">
+              <a:buNone/>
+            </a:pPr>
+            <a:r>
+              <a:rPr lang="en-US" sz="1150" b="1" dirty="0">
+                <a:solidFill>
+                  <a:srgbClr val="8A6594"/>
+                </a:solidFill>
+                <a:latin typeface="Calibri" pitchFamily="34" charset="0"/>
+                <a:ea typeface="Calibri" pitchFamily="34" charset="-122"/>
+                <a:cs typeface="Calibri" pitchFamily="34" charset="-120"/>
+              </a:rPr>
+              <a:t>freio TDAH: já era mais baixo antes;</a:t>
+            </a:r>
+            <a:endParaRPr lang="en-US" sz="1150" dirty="0"/>
+          </a:p>
+          <a:p>
+            <a:pPr indent="0" marL="0">
+              <a:buNone/>
+            </a:pPr>
+            <a:r>
+              <a:rPr lang="en-US" sz="1150" b="1" dirty="0">
+                <a:solidFill>
+                  <a:srgbClr val="8A6594"/>
+                </a:solidFill>
+                <a:latin typeface="Calibri" pitchFamily="34" charset="0"/>
+                <a:ea typeface="Calibri" pitchFamily="34" charset="-122"/>
+                <a:cs typeface="Calibri" pitchFamily="34" charset="-120"/>
+              </a:rPr>
+              <a:t>a escola só revelou</a:t>
+            </a:r>
+            <a:endParaRPr lang="en-US" sz="1150" dirty="0"/>
+          </a:p>
+        </p:txBody>
+      </p:sp>
+      <p:sp>
+        <p:nvSpPr>
+          <p:cNvPr id="15" name="Shape 13"/>
+          <p:cNvSpPr/>
+          <p:nvPr/>
+        </p:nvSpPr>
+        <p:spPr>
+          <a:xfrm>
             <a:off x="1463040" y="4846320"/>
-            <a:ext cx="3566160" cy="0"/>
+            <a:ext cx="1554480" cy="0"/>
           </a:xfrm>
           <a:prstGeom prst="line">
             <a:avLst/>
@@ -23223,14 +23518,14 @@
       </p:sp>
       <p:sp>
         <p:nvSpPr>
-          <p:cNvPr id="13" name="Shape 11"/>
-          <p:cNvSpPr/>
-          <p:nvPr/>
-        </p:nvSpPr>
-        <p:spPr>
-          <a:xfrm>
-            <a:off x="5029200" y="3017520"/>
-            <a:ext cx="0" cy="1828800"/>
+          <p:cNvPr id="16" name="Shape 14"/>
+          <p:cNvSpPr/>
+          <p:nvPr/>
+        </p:nvSpPr>
+        <p:spPr>
+          <a:xfrm>
+            <a:off x="3017520" y="4572000"/>
+            <a:ext cx="0" cy="274320"/>
           </a:xfrm>
           <a:prstGeom prst="line">
             <a:avLst/>
@@ -23246,14 +23541,14 @@
       </p:sp>
       <p:sp>
         <p:nvSpPr>
-          <p:cNvPr id="14" name="Shape 12"/>
-          <p:cNvSpPr/>
-          <p:nvPr/>
-        </p:nvSpPr>
-        <p:spPr>
-          <a:xfrm>
-            <a:off x="5029200" y="3017520"/>
-            <a:ext cx="5303520" cy="-274320"/>
+          <p:cNvPr id="17" name="Shape 15"/>
+          <p:cNvSpPr/>
+          <p:nvPr/>
+        </p:nvSpPr>
+        <p:spPr>
+          <a:xfrm>
+            <a:off x="3017520" y="4572000"/>
+            <a:ext cx="2011680" cy="0"/>
           </a:xfrm>
           <a:prstGeom prst="line">
             <a:avLst/>
@@ -23269,14 +23564,60 @@
       </p:sp>
       <p:sp>
         <p:nvSpPr>
-          <p:cNvPr id="15" name="Text 13"/>
-          <p:cNvSpPr/>
-          <p:nvPr/>
-        </p:nvSpPr>
-        <p:spPr>
-          <a:xfrm>
-            <a:off x="5486400" y="2395728"/>
-            <a:ext cx="3291840" cy="365760"/>
+          <p:cNvPr id="18" name="Shape 16"/>
+          <p:cNvSpPr/>
+          <p:nvPr/>
+        </p:nvSpPr>
+        <p:spPr>
+          <a:xfrm>
+            <a:off x="5029200" y="3017520"/>
+            <a:ext cx="0" cy="1554480"/>
+          </a:xfrm>
+          <a:prstGeom prst="line">
+            <a:avLst/>
+          </a:prstGeom>
+          <a:noFill/>
+          <a:ln w="50800">
+            <a:solidFill>
+              <a:srgbClr val="E96030"/>
+            </a:solidFill>
+            <a:prstDash val="solid"/>
+          </a:ln>
+        </p:spPr>
+      </p:sp>
+      <p:sp>
+        <p:nvSpPr>
+          <p:cNvPr id="19" name="Shape 17"/>
+          <p:cNvSpPr/>
+          <p:nvPr/>
+        </p:nvSpPr>
+        <p:spPr>
+          <a:xfrm>
+            <a:off x="5029200" y="3017520"/>
+            <a:ext cx="5303520" cy="-274320"/>
+          </a:xfrm>
+          <a:prstGeom prst="line">
+            <a:avLst/>
+          </a:prstGeom>
+          <a:noFill/>
+          <a:ln w="50800">
+            <a:solidFill>
+              <a:srgbClr val="E96030"/>
+            </a:solidFill>
+            <a:prstDash val="solid"/>
+          </a:ln>
+        </p:spPr>
+      </p:sp>
+      <p:sp>
+        <p:nvSpPr>
+          <p:cNvPr id="20" name="Text 18"/>
+          <p:cNvSpPr/>
+          <p:nvPr/>
+        </p:nvSpPr>
+        <p:spPr>
+          <a:xfrm>
+            <a:off x="5257800" y="2395728"/>
+            <a:ext cx="4023360" cy="365760"/>
           </a:xfrm>
           <a:prstGeom prst="rect">
             <a:avLst/>
@@ -23300,7 +23641,7 @@
                 <a:ea typeface="Calibri" pitchFamily="34" charset="-122"/>
                 <a:cs typeface="Calibri" pitchFamily="34" charset="-120"/>
               </a:rPr>
-              <a:t>demanda por autorregulação</a:t>
+              <a:t>demanda por autorregulação (escada)</a:t>
             </a:r>
             <a:endParaRPr lang="en-US" sz="1250" dirty="0"/>
           </a:p>
@@ -23308,7 +23649,46 @@
       </p:sp>
       <p:sp>
         <p:nvSpPr>
-          <p:cNvPr id="16" name="Text 14"/>
+          <p:cNvPr id="21" name="Text 19"/>
+          <p:cNvSpPr/>
+          <p:nvPr/>
+        </p:nvSpPr>
+        <p:spPr>
+          <a:xfrm>
+            <a:off x="3063240" y="4645152"/>
+            <a:ext cx="1645920" cy="274320"/>
+          </a:xfrm>
+          <a:prstGeom prst="rect">
+            <a:avLst/>
+          </a:prstGeom>
+          <a:noFill/>
+          <a:ln/>
+        </p:spPr>
+        <p:txBody>
+          <a:bodyPr wrap="square" rtlCol="0" anchor="t"/>
+          <a:lstStyle/>
+          <a:p>
+            <a:pPr indent="0" marL="0">
+              <a:buNone/>
+            </a:pPr>
+            <a:r>
+              <a:rPr lang="en-US" sz="1050" dirty="0">
+                <a:solidFill>
+                  <a:srgbClr val="B84A1F"/>
+                </a:solidFill>
+                <a:latin typeface="Calibri" pitchFamily="34" charset="0"/>
+                <a:ea typeface="Calibri" pitchFamily="34" charset="-122"/>
+                <a:cs typeface="Calibri" pitchFamily="34" charset="-120"/>
+              </a:rPr>
+              <a:t>pré-escola</a:t>
+            </a:r>
+            <a:endParaRPr lang="en-US" sz="1050" dirty="0"/>
+          </a:p>
+        </p:txBody>
+      </p:sp>
+      <p:sp>
+        <p:nvSpPr>
+          <p:cNvPr id="22" name="Text 20"/>
           <p:cNvSpPr/>
           <p:nvPr/>
         </p:nvSpPr>
@@ -23347,7 +23727,7 @@
       </p:sp>
       <p:sp>
         <p:nvSpPr>
-          <p:cNvPr id="17" name="Shape 15"/>
+          <p:cNvPr id="23" name="Shape 21"/>
           <p:cNvSpPr/>
           <p:nvPr/>
         </p:nvSpPr>
@@ -23369,7 +23749,7 @@
       </p:sp>
       <p:sp>
         <p:nvSpPr>
-          <p:cNvPr id="18" name="Text 16"/>
+          <p:cNvPr id="24" name="Text 22"/>
           <p:cNvSpPr/>
           <p:nvPr/>
         </p:nvSpPr>
@@ -23425,7 +23805,7 @@
       </p:sp>
       <p:sp>
         <p:nvSpPr>
-          <p:cNvPr id="19" name="Text 17"/>
+          <p:cNvPr id="25" name="Text 23"/>
           <p:cNvSpPr/>
           <p:nvPr/>
         </p:nvSpPr>
@@ -23464,7 +23844,7 @@
       </p:sp>
       <p:sp>
         <p:nvSpPr>
-          <p:cNvPr id="20" name="Text 18"/>
+          <p:cNvPr id="26" name="Text 24"/>
           <p:cNvSpPr/>
           <p:nvPr/>
         </p:nvSpPr>
@@ -28251,7 +28631,7 @@
                 <a:ea typeface="Georgia" pitchFamily="34" charset="-122"/>
                 <a:cs typeface="Georgia" pitchFamily="34" charset="-120"/>
               </a:rPr>
-              <a:t>A moral sai da heteronomia: perto dos 8, a regra deixa de ser sagrada e a intenção passa a contar.</a:t>
+              <a:t>A moral sai da heteronomia: entre os 7 e os 10, a regra deixa de ser sagrada e a intenção passa a contar.</a:t>
             </a:r>
             <a:endParaRPr lang="en-US" sz="2100" dirty="0"/>
           </a:p>
@@ -28845,8 +29225,8 @@
         </p:nvSpPr>
         <p:spPr>
           <a:xfrm>
-            <a:off x="822960" y="3429000"/>
-            <a:ext cx="10515600" cy="457200"/>
+            <a:off x="822960" y="3383280"/>
+            <a:ext cx="10515600" cy="594360"/>
           </a:xfrm>
           <a:prstGeom prst="rect">
             <a:avLst/>
@@ -28862,7 +29242,7 @@
               <a:buNone/>
             </a:pPr>
             <a:r>
-              <a:rPr lang="en-US" sz="1500" i="1" dirty="0">
+              <a:rPr lang="en-US" sz="1350" i="1" dirty="0">
                 <a:solidFill>
                   <a:srgbClr val="56365F"/>
                 </a:solidFill>
@@ -28870,9 +29250,9 @@
                 <a:ea typeface="Calibri" pitchFamily="34" charset="-122"/>
                 <a:cs typeface="Calibri" pitchFamily="34" charset="-120"/>
               </a:rPr>
-              <a:t>a moeda da aceitação é exatamente o que os atos anteriores construíram: regular a expressão emocional + ler mentes</a:t>
-            </a:r>
-            <a:endParaRPr lang="en-US" sz="1500" dirty="0"/>
+              <a:t>negligenciada = ignorada PELOS PARES, sem rejeição ativa (não confundir com negligência parental). A moeda da aceitação é o que os atos anteriores construíram: regular a expressão emocional + ler mentes.</a:t>
+            </a:r>
+            <a:endParaRPr lang="en-US" sz="1350" dirty="0"/>
           </a:p>
         </p:txBody>
       </p:sp>
@@ -32451,7 +32831,46 @@
       </p:sp>
       <p:sp>
         <p:nvSpPr>
-          <p:cNvPr id="19" name="Shape 17"/>
+          <p:cNvPr id="19" name="Text 17"/>
+          <p:cNvSpPr/>
+          <p:nvPr/>
+        </p:nvSpPr>
+        <p:spPr>
+          <a:xfrm>
+            <a:off x="1280160" y="5166360"/>
+            <a:ext cx="9601200" cy="320040"/>
+          </a:xfrm>
+          <a:prstGeom prst="rect">
+            <a:avLst/>
+          </a:prstGeom>
+          <a:noFill/>
+          <a:ln/>
+        </p:spPr>
+        <p:txBody>
+          <a:bodyPr wrap="square" rtlCol="0" anchor="t"/>
+          <a:lstStyle/>
+          <a:p>
+            <a:pPr indent="0" marL="0">
+              <a:buNone/>
+            </a:pPr>
+            <a:r>
+              <a:rPr lang="en-US" sz="1200" i="1" dirty="0">
+                <a:solidFill>
+                  <a:srgbClr val="B84A1F"/>
+                </a:solidFill>
+                <a:latin typeface="Calibri" pitchFamily="34" charset="0"/>
+                <a:ea typeface="Calibri" pitchFamily="34" charset="-122"/>
+                <a:cs typeface="Calibri" pitchFamily="34" charset="-120"/>
+              </a:rPr>
+              <a:t>posição no mapa = etapa da transferência que costuma falhar, NÃO idade de início</a:t>
+            </a:r>
+            <a:endParaRPr lang="en-US" sz="1200" dirty="0"/>
+          </a:p>
+        </p:txBody>
+      </p:sp>
+      <p:sp>
+        <p:nvSpPr>
+          <p:cNvPr id="20" name="Shape 18"/>
           <p:cNvSpPr/>
           <p:nvPr/>
         </p:nvSpPr>
@@ -32478,7 +32897,7 @@
       </p:sp>
       <p:sp>
         <p:nvSpPr>
-          <p:cNvPr id="20" name="Shape 18"/>
+          <p:cNvPr id="21" name="Shape 19"/>
           <p:cNvSpPr/>
           <p:nvPr/>
         </p:nvSpPr>
@@ -32498,7 +32917,7 @@
       </p:sp>
       <p:sp>
         <p:nvSpPr>
-          <p:cNvPr id="21" name="Text 19"/>
+          <p:cNvPr id="22" name="Text 20"/>
           <p:cNvSpPr/>
           <p:nvPr/>
         </p:nvSpPr>
@@ -32537,7 +32956,7 @@
       </p:sp>
       <p:sp>
         <p:nvSpPr>
-          <p:cNvPr id="22" name="Text 20"/>
+          <p:cNvPr id="23" name="Text 21"/>
           <p:cNvSpPr/>
           <p:nvPr/>
         </p:nvSpPr>
@@ -32576,7 +32995,7 @@
       </p:sp>
       <p:sp>
         <p:nvSpPr>
-          <p:cNvPr id="23" name="Shape 21"/>
+          <p:cNvPr id="24" name="Shape 22"/>
           <p:cNvSpPr/>
           <p:nvPr/>
         </p:nvSpPr>
@@ -32599,7 +33018,7 @@
       </p:sp>
       <p:sp>
         <p:nvSpPr>
-          <p:cNvPr id="24" name="Shape 22"/>
+          <p:cNvPr id="25" name="Shape 23"/>
           <p:cNvSpPr/>
           <p:nvPr/>
         </p:nvSpPr>
@@ -32626,7 +33045,7 @@
       </p:sp>
       <p:sp>
         <p:nvSpPr>
-          <p:cNvPr id="25" name="Shape 23"/>
+          <p:cNvPr id="26" name="Shape 24"/>
           <p:cNvSpPr/>
           <p:nvPr/>
         </p:nvSpPr>
@@ -32646,7 +33065,7 @@
       </p:sp>
       <p:sp>
         <p:nvSpPr>
-          <p:cNvPr id="26" name="Text 24"/>
+          <p:cNvPr id="27" name="Text 25"/>
           <p:cNvSpPr/>
           <p:nvPr/>
         </p:nvSpPr>
@@ -32685,7 +33104,7 @@
       </p:sp>
       <p:sp>
         <p:nvSpPr>
-          <p:cNvPr id="27" name="Text 25"/>
+          <p:cNvPr id="28" name="Text 26"/>
           <p:cNvSpPr/>
           <p:nvPr/>
         </p:nvSpPr>
@@ -32724,7 +33143,7 @@
       </p:sp>
       <p:sp>
         <p:nvSpPr>
-          <p:cNvPr id="28" name="Shape 26"/>
+          <p:cNvPr id="29" name="Shape 27"/>
           <p:cNvSpPr/>
           <p:nvPr/>
         </p:nvSpPr>
@@ -32747,7 +33166,7 @@
       </p:sp>
       <p:sp>
         <p:nvSpPr>
-          <p:cNvPr id="29" name="Shape 27"/>
+          <p:cNvPr id="30" name="Shape 28"/>
           <p:cNvSpPr/>
           <p:nvPr/>
         </p:nvSpPr>
@@ -32774,7 +33193,7 @@
       </p:sp>
       <p:sp>
         <p:nvSpPr>
-          <p:cNvPr id="30" name="Shape 28"/>
+          <p:cNvPr id="31" name="Shape 29"/>
           <p:cNvSpPr/>
           <p:nvPr/>
         </p:nvSpPr>
@@ -32794,7 +33213,7 @@
       </p:sp>
       <p:sp>
         <p:nvSpPr>
-          <p:cNvPr id="31" name="Text 29"/>
+          <p:cNvPr id="32" name="Text 30"/>
           <p:cNvSpPr/>
           <p:nvPr/>
         </p:nvSpPr>
@@ -32833,7 +33252,7 @@
       </p:sp>
       <p:sp>
         <p:nvSpPr>
-          <p:cNvPr id="32" name="Text 30"/>
+          <p:cNvPr id="33" name="Text 31"/>
           <p:cNvSpPr/>
           <p:nvPr/>
         </p:nvSpPr>
@@ -32872,7 +33291,7 @@
       </p:sp>
       <p:sp>
         <p:nvSpPr>
-          <p:cNvPr id="33" name="Shape 31"/>
+          <p:cNvPr id="34" name="Shape 32"/>
           <p:cNvSpPr/>
           <p:nvPr/>
         </p:nvSpPr>
@@ -32895,7 +33314,7 @@
       </p:sp>
       <p:sp>
         <p:nvSpPr>
-          <p:cNvPr id="34" name="Shape 32"/>
+          <p:cNvPr id="35" name="Shape 33"/>
           <p:cNvSpPr/>
           <p:nvPr/>
         </p:nvSpPr>
@@ -32922,7 +33341,7 @@
       </p:sp>
       <p:sp>
         <p:nvSpPr>
-          <p:cNvPr id="35" name="Shape 33"/>
+          <p:cNvPr id="36" name="Shape 34"/>
           <p:cNvSpPr/>
           <p:nvPr/>
         </p:nvSpPr>
@@ -32942,7 +33361,7 @@
       </p:sp>
       <p:sp>
         <p:nvSpPr>
-          <p:cNvPr id="36" name="Text 34"/>
+          <p:cNvPr id="37" name="Text 35"/>
           <p:cNvSpPr/>
           <p:nvPr/>
         </p:nvSpPr>
@@ -32981,7 +33400,7 @@
       </p:sp>
       <p:sp>
         <p:nvSpPr>
-          <p:cNvPr id="37" name="Text 35"/>
+          <p:cNvPr id="38" name="Text 36"/>
           <p:cNvSpPr/>
           <p:nvPr/>
         </p:nvSpPr>
@@ -33020,7 +33439,7 @@
       </p:sp>
       <p:sp>
         <p:nvSpPr>
-          <p:cNvPr id="38" name="Shape 36"/>
+          <p:cNvPr id="39" name="Shape 37"/>
           <p:cNvSpPr/>
           <p:nvPr/>
         </p:nvSpPr>
@@ -33043,7 +33462,7 @@
       </p:sp>
       <p:sp>
         <p:nvSpPr>
-          <p:cNvPr id="39" name="Text 37"/>
+          <p:cNvPr id="40" name="Text 38"/>
           <p:cNvSpPr/>
           <p:nvPr/>
         </p:nvSpPr>
@@ -33082,7 +33501,7 @@
       </p:sp>
       <p:sp>
         <p:nvSpPr>
-          <p:cNvPr id="40" name="Text 38"/>
+          <p:cNvPr id="41" name="Text 39"/>
           <p:cNvSpPr/>
           <p:nvPr/>
         </p:nvSpPr>
@@ -33125,7 +33544,7 @@
       </p:sp>
       <p:sp>
         <p:nvSpPr>
-          <p:cNvPr id="41" name="Shape 39"/>
+          <p:cNvPr id="42" name="Shape 40"/>
           <p:cNvSpPr/>
           <p:nvPr/>
         </p:nvSpPr>
@@ -33149,7 +33568,7 @@
       </p:sp>
       <p:sp>
         <p:nvSpPr>
-          <p:cNvPr id="42" name="Text 40"/>
+          <p:cNvPr id="43" name="Text 41"/>
           <p:cNvSpPr/>
           <p:nvPr/>
         </p:nvSpPr>
@@ -33192,7 +33611,7 @@
       </p:sp>
       <p:sp>
         <p:nvSpPr>
-          <p:cNvPr id="43" name="Shape 41"/>
+          <p:cNvPr id="44" name="Shape 42"/>
           <p:cNvSpPr/>
           <p:nvPr/>
         </p:nvSpPr>
@@ -33216,7 +33635,7 @@
       </p:sp>
       <p:sp>
         <p:nvSpPr>
-          <p:cNvPr id="44" name="Text 42"/>
+          <p:cNvPr id="45" name="Text 43"/>
           <p:cNvSpPr/>
           <p:nvPr/>
         </p:nvSpPr>
@@ -33259,7 +33678,7 @@
       </p:sp>
       <p:sp>
         <p:nvSpPr>
-          <p:cNvPr id="45" name="Shape 43"/>
+          <p:cNvPr id="46" name="Shape 44"/>
           <p:cNvSpPr/>
           <p:nvPr/>
         </p:nvSpPr>
@@ -33283,7 +33702,7 @@
       </p:sp>
       <p:sp>
         <p:nvSpPr>
-          <p:cNvPr id="46" name="Text 44"/>
+          <p:cNvPr id="47" name="Text 45"/>
           <p:cNvSpPr/>
           <p:nvPr/>
         </p:nvSpPr>
@@ -34561,6 +34980,45 @@
           </a:graphicData>
         </a:graphic>
       </p:graphicFrame>
+      <p:sp>
+        <p:nvSpPr>
+          <p:cNvPr id="7" name="Text 4"/>
+          <p:cNvSpPr/>
+          <p:nvPr/>
+        </p:nvSpPr>
+        <p:spPr>
+          <a:xfrm>
+            <a:off x="8897112" y="6455664"/>
+            <a:ext cx="2560320" cy="292608"/>
+          </a:xfrm>
+          <a:prstGeom prst="rect">
+            <a:avLst/>
+          </a:prstGeom>
+          <a:noFill/>
+          <a:ln/>
+        </p:spPr>
+        <p:txBody>
+          <a:bodyPr wrap="square" rtlCol="0" anchor="ctr"/>
+          <a:lstStyle/>
+          <a:p>
+            <a:pPr algn="r" indent="0" marL="0">
+              <a:buNone/>
+            </a:pPr>
+            <a:r>
+              <a:rPr lang="en-US" sz="1000" i="1" dirty="0">
+                <a:solidFill>
+                  <a:srgbClr val="8A6594"/>
+                </a:solidFill>
+                <a:latin typeface="Calibri" pitchFamily="34" charset="0"/>
+                <a:ea typeface="Calibri" pitchFamily="34" charset="-122"/>
+                <a:cs typeface="Calibri" pitchFamily="34" charset="-120"/>
+              </a:rPr>
+              <a:t>aprofundamento: apêndice D</a:t>
+            </a:r>
+            <a:endParaRPr lang="en-US" sz="1000" dirty="0"/>
+          </a:p>
+        </p:txBody>
+      </p:sp>
     </p:spTree>
   </p:cSld>
   <p:clrMapOvr>
@@ -35693,12 +36151,12 @@
         </p:nvSpPr>
         <p:spPr>
           <a:xfrm>
-            <a:off x="640080" y="5806440"/>
-            <a:ext cx="10881360" cy="640080"/>
+            <a:off x="640080" y="5623560"/>
+            <a:ext cx="10881360" cy="868680"/>
           </a:xfrm>
           <a:prstGeom prst="roundRect">
             <a:avLst>
-              <a:gd name="adj" fmla="val 10000"/>
+              <a:gd name="adj" fmla="val 7368"/>
             </a:avLst>
           </a:prstGeom>
           <a:solidFill>
@@ -35720,8 +36178,8 @@
         </p:nvSpPr>
         <p:spPr>
           <a:xfrm>
-            <a:off x="914400" y="5943600"/>
-            <a:ext cx="10332720" cy="411480"/>
+            <a:off x="914400" y="5760720"/>
+            <a:ext cx="10332720" cy="640080"/>
           </a:xfrm>
           <a:prstGeom prst="rect">
             <a:avLst/>
@@ -35737,7 +36195,7 @@
               <a:buNone/>
             </a:pPr>
             <a:r>
-              <a:rPr lang="en-US" sz="1400" b="1" dirty="0">
+              <a:rPr lang="en-US" sz="1300" dirty="0">
                 <a:solidFill>
                   <a:srgbClr val="56365F"/>
                 </a:solidFill>
@@ -35745,9 +36203,9 @@
                 <a:ea typeface="Calibri" pitchFamily="34" charset="-122"/>
                 <a:cs typeface="Calibri" pitchFamily="34" charset="-120"/>
               </a:rPr>
-              <a:t>Documento de apoio completo (com páginas, scripts e ressalvas) disponível na plataforma.</a:t>
-            </a:r>
-            <a:endParaRPr lang="en-US" sz="1400" dirty="0"/>
+              <a:t>Documento de apoio completo (páginas, scripts e ressalvas) na plataforma. Aprofundamento no apêndice: A anatomia da birra · B as duas curvas do TDAH · C falsa crença · D perguntas frequentes.</a:t>
+            </a:r>
+            <a:endParaRPr lang="en-US" sz="1300" dirty="0"/>
           </a:p>
         </p:txBody>
       </p:sp>
@@ -35894,7 +36352,7 @@
                 <a:ea typeface="Georgia" pitchFamily="34" charset="-122"/>
                 <a:cs typeface="Georgia" pitchFamily="34" charset="-120"/>
               </a:rPr>
-              <a:t>Apêndice: módulos de aprofundamento</a:t>
+              <a:t>Apêndice de aprofundamento</a:t>
             </a:r>
             <a:endParaRPr lang="en-US" sz="4000" dirty="0"/>
           </a:p>
@@ -39990,7 +40448,7 @@
               <a:buNone/>
             </a:pPr>
             <a:r>
-              <a:rPr lang="en-US" sz="1350" i="1" dirty="0">
+              <a:rPr lang="en-US" sz="1300" i="1" dirty="0">
                 <a:solidFill>
                   <a:srgbClr val="56365F"/>
                 </a:solidFill>
@@ -39998,9 +40456,9 @@
                 <a:ea typeface="Calibri" pitchFamily="34" charset="-122"/>
                 <a:cs typeface="Calibri" pitchFamily="34" charset="-120"/>
               </a:rPr>
-              <a:t>A cena (do vídeo da aula): criança de ~2 anos pede doce no caixa; mãe diz não; grito e chão; após 90 segundos, a mãe entrega o doce e o grito para.</a:t>
-            </a:r>
-            <a:endParaRPr lang="en-US" sz="1350" dirty="0"/>
+              <a:t>A cena-tipo (padrão do vídeo V2 da aula; confirme que o clipe escolhido contém o ciclo completo): criança de ~2 anos pede doce no caixa; mãe diz não; grito e chão; a mãe entrega o doce e o grito para.</a:t>
+            </a:r>
+            <a:endParaRPr lang="en-US" sz="1300" dirty="0"/>
           </a:p>
         </p:txBody>
       </p:sp>

</xml_diff>